<commit_message>
Slides: 108 px cover titles on sd-01-050, sd-02-005..007; PPTX re-exported
Co-Authored-By: Claude Opus 5.5 <noreply@anthropic.com>
Claude-Session: https://claude.ai/code/session_01McBLtMnJbTnB94NeVs8a2V
</commit_message>
<xml_diff>
--- a/system-design-101/vi/lessons/sd-01-050/slides/sd-01-050.pptx
+++ b/system-design-101/vi/lessons/sd-01-050/slides/sd-01-050.pptx
@@ -1790,7 +1790,7 @@
         <p:spPr>
           <a:xfrm>
             <a:off x="914400" y="1428750"/>
-            <a:ext cx="9144000" cy="4219575"/>
+            <a:ext cx="9144000" cy="4000500"/>
           </a:xfrm>
           <a:prstGeom prst="rect">
             <a:avLst/>
@@ -1799,17 +1799,17 @@
           <a:ln/>
         </p:spPr>
         <p:txBody>
-          <a:bodyPr wrap="square" lIns="0" tIns="71079" rIns="0" bIns="-71079" rtlCol="0" anchor="t"/>
+          <a:bodyPr wrap="square" lIns="0" tIns="72009" rIns="0" bIns="-72009" rtlCol="0" anchor="t"/>
           <a:lstStyle/>
           <a:p>
             <a:pPr algn="l" indent="0" marL="0">
               <a:lnSpc>
-                <a:spcPts val="8316"/>
+                <a:spcPts val="8424"/>
               </a:lnSpc>
               <a:buNone/>
             </a:pPr>
             <a:r>
-              <a:rPr lang="en-US" sz="7996" dirty="0" spc="4" kern="0">
+              <a:rPr lang="en-US" sz="8100" dirty="0" spc="0" kern="0">
                 <a:solidFill>
                   <a:srgbClr val="F3EEE3"/>
                 </a:solidFill>
@@ -1820,7 +1820,7 @@
               <a:t>Sáu</a:t>
             </a:r>
             <a:r>
-              <a:rPr lang="en-US" sz="7996" dirty="0" spc="-1" kern="0">
+              <a:rPr lang="en-US" sz="8100" dirty="0" spc="-2" kern="0">
                 <a:solidFill>
                   <a:srgbClr val="F3EEE3"/>
                 </a:solidFill>
@@ -1831,7 +1831,7 @@
               <a:t> giao</a:t>
             </a:r>
             <a:r>
-              <a:rPr lang="en-US" sz="7996" dirty="0" spc="-65" kern="0">
+              <a:rPr lang="en-US" sz="8100" dirty="0" spc="-64" kern="0">
                 <a:solidFill>
                   <a:srgbClr val="F3EEE3"/>
                 </a:solidFill>
@@ -1842,7 +1842,7 @@
               <a:t> thức</a:t>
             </a:r>
             <a:r>
-              <a:rPr lang="en-US" sz="7996" dirty="0" spc="-1" kern="0">
+              <a:rPr lang="en-US" sz="8100" dirty="0" spc="-1" kern="0">
                 <a:solidFill>
                   <a:srgbClr val="F3EEE3"/>
                 </a:solidFill>
@@ -1853,7 +1853,7 @@
               <a:t> API:</a:t>
             </a:r>
             <a:r>
-              <a:rPr lang="en-US" sz="7996" dirty="0" spc="-4" kern="0">
+              <a:rPr lang="en-US" sz="8100" dirty="0" spc="2" kern="0">
                 <a:solidFill>
                   <a:srgbClr val="F3EEE3"/>
                 </a:solidFill>
@@ -1864,7 +1864,7 @@
               <a:t> chọn</a:t>
             </a:r>
             <a:r>
-              <a:rPr lang="en-US" sz="7996" dirty="0" spc="-3" kern="0">
+              <a:rPr lang="en-US" sz="8100" dirty="0" spc="1" kern="0">
                 <a:solidFill>
                   <a:srgbClr val="F3EEE3"/>
                 </a:solidFill>
@@ -1875,7 +1875,7 @@
               <a:t> theo</a:t>
             </a:r>
             <a:r>
-              <a:rPr lang="en-US" sz="7996" dirty="0" spc="4" kern="0">
+              <a:rPr lang="en-US" sz="8100" dirty="0" spc="2" kern="0">
                 <a:solidFill>
                   <a:srgbClr val="F3EEE3"/>
                 </a:solidFill>
@@ -1886,7 +1886,7 @@
               <a:t> kiểu</a:t>
             </a:r>
             <a:r>
-              <a:rPr lang="en-US" sz="7996" dirty="0" spc="-5" kern="0">
+              <a:rPr lang="en-US" sz="8100" dirty="0" spc="-1" kern="0">
                 <a:solidFill>
                   <a:srgbClr val="F3EEE3"/>
                 </a:solidFill>
@@ -1897,7 +1897,7 @@
               <a:t> hội</a:t>
             </a:r>
             <a:r>
-              <a:rPr lang="en-US" sz="7996" dirty="0" spc="-7" kern="0">
+              <a:rPr lang="en-US" sz="8100" dirty="0" spc="-7" kern="0">
                 <a:solidFill>
                   <a:srgbClr val="F3EEE3"/>
                 </a:solidFill>
@@ -1907,7 +1907,7 @@
               </a:rPr>
               <a:t> thoại</a:t>
             </a:r>
-            <a:endParaRPr lang="en-US" sz="7996" dirty="0"/>
+            <a:endParaRPr lang="en-US" sz="8100" dirty="0"/>
           </a:p>
         </p:txBody>
       </p:sp>

</xml_diff>

<commit_message>
sd-01-050: a SOAP service description is published separately, not sent with each request
Lesson line and deck slide 4 (bullet and the outer layer label); PPTX re-exported.

Co-Authored-By: Claude Opus 5.5 <noreply@anthropic.com>
Claude-Session: https://claude.ai/code/session_01McBLtMnJbTnB94NeVs8a2V
</commit_message>
<xml_diff>
--- a/system-design-101/vi/lessons/sd-01-050/slides/sd-01-050.pptx
+++ b/system-design-101/vi/lessons/sd-01-050/slides/sd-01-050.pptx
@@ -8266,7 +8266,7 @@
               <a:buChar char="•"/>
             </a:pPr>
             <a:r>
-              <a:rPr lang="en-US" sz="2700" dirty="0" spc="-49" kern="0">
+              <a:rPr lang="en-US" sz="2700" dirty="0" spc="-1" kern="0">
                 <a:solidFill>
                   <a:srgbClr val="C4C8D6"/>
                 </a:solidFill>
@@ -8274,10 +8274,10 @@
                 <a:ea typeface="Be Vietnam Pro" pitchFamily="34" charset="-122"/>
                 <a:cs typeface="Be Vietnam Pro" pitchFamily="34" charset="-120"/>
               </a:rPr>
-              <a:t>Kèm</a:t>
-            </a:r>
-            <a:r>
-              <a:rPr lang="en-US" sz="2700" dirty="0" spc="-5" kern="0">
+              <a:t>Hợp</a:t>
+            </a:r>
+            <a:r>
+              <a:rPr lang="en-US" sz="2700" dirty="0" spc="9" kern="0">
                 <a:solidFill>
                   <a:srgbClr val="C4C8D6"/>
                 </a:solidFill>
@@ -8285,10 +8285,10 @@
                 <a:ea typeface="Be Vietnam Pro" pitchFamily="34" charset="-122"/>
                 <a:cs typeface="Be Vietnam Pro" pitchFamily="34" charset="-120"/>
               </a:rPr>
-              <a:t> bản</a:t>
-            </a:r>
-            <a:r>
-              <a:rPr lang="en-US" sz="2700" dirty="0" spc="-3" kern="0">
+              <a:t> đồng</a:t>
+            </a:r>
+            <a:r>
+              <a:rPr lang="en-US" sz="2700" dirty="0" spc="-2" kern="0">
                 <a:solidFill>
                   <a:srgbClr val="C4C8D6"/>
                 </a:solidFill>
@@ -8296,10 +8296,10 @@
                 <a:ea typeface="Be Vietnam Pro" pitchFamily="34" charset="-122"/>
                 <a:cs typeface="Be Vietnam Pro" pitchFamily="34" charset="-120"/>
               </a:rPr>
-              <a:t> mô</a:t>
-            </a:r>
-            <a:r>
-              <a:rPr lang="en-US" sz="2700" dirty="0" spc="-17" kern="0">
+              <a:t> dịch</a:t>
+            </a:r>
+            <a:r>
+              <a:rPr lang="en-US" sz="2700" dirty="0" spc="1" kern="0">
                 <a:solidFill>
                   <a:srgbClr val="C4C8D6"/>
                 </a:solidFill>
@@ -8307,7 +8307,29 @@
                 <a:ea typeface="Be Vietnam Pro" pitchFamily="34" charset="-122"/>
                 <a:cs typeface="Be Vietnam Pro" pitchFamily="34" charset="-120"/>
               </a:rPr>
-              <a:t> tả</a:t>
+              <a:t> vụ,</a:t>
+            </a:r>
+            <a:r>
+              <a:rPr lang="en-US" sz="2700" dirty="0" spc="-2" kern="0">
+                <a:solidFill>
+                  <a:srgbClr val="C4C8D6"/>
+                </a:solidFill>
+                <a:latin typeface="Be Vietnam Pro" pitchFamily="34" charset="0"/>
+                <a:ea typeface="Be Vietnam Pro" pitchFamily="34" charset="-122"/>
+                <a:cs typeface="Be Vietnam Pro" pitchFamily="34" charset="-120"/>
+              </a:rPr>
+              <a:t> nếu</a:t>
+            </a:r>
+            <a:r>
+              <a:rPr lang="en-US" sz="2700" dirty="0" spc="1" kern="0">
+                <a:solidFill>
+                  <a:srgbClr val="C4C8D6"/>
+                </a:solidFill>
+                <a:latin typeface="Be Vietnam Pro" pitchFamily="34" charset="0"/>
+                <a:ea typeface="Be Vietnam Pro" pitchFamily="34" charset="-122"/>
+                <a:cs typeface="Be Vietnam Pro" pitchFamily="34" charset="-120"/>
+              </a:rPr>
+              <a:t> có,</a:t>
             </a:r>
             <a:r>
               <a:rPr lang="en-US" sz="2700" dirty="0" spc="-1" kern="0">
@@ -8318,10 +8340,10 @@
                 <a:ea typeface="Be Vietnam Pro" pitchFamily="34" charset="-122"/>
                 <a:cs typeface="Be Vietnam Pro" pitchFamily="34" charset="-120"/>
               </a:rPr>
-              <a:t> dịch</a:t>
-            </a:r>
-            <a:r>
-              <a:rPr lang="en-US" sz="2700" dirty="0" spc="-2" kern="0">
+              <a:t> công</a:t>
+            </a:r>
+            <a:r>
+              <a:rPr lang="en-US" sz="2700" dirty="0" spc="-7" kern="0">
                 <a:solidFill>
                   <a:srgbClr val="C4C8D6"/>
                 </a:solidFill>
@@ -8329,10 +8351,10 @@
                 <a:ea typeface="Be Vietnam Pro" pitchFamily="34" charset="-122"/>
                 <a:cs typeface="Be Vietnam Pro" pitchFamily="34" charset="-120"/>
               </a:rPr>
-              <a:t> vụ</a:t>
-            </a:r>
-            <a:r>
-              <a:rPr lang="en-US" sz="2700" dirty="0" spc="-1" kern="0">
+              <a:t> bố</a:t>
+            </a:r>
+            <a:r>
+              <a:rPr lang="en-US" sz="2700" dirty="0" spc="5" kern="0">
                 <a:solidFill>
                   <a:srgbClr val="C4C8D6"/>
                 </a:solidFill>
@@ -8340,29 +8362,7 @@
                 <a:ea typeface="Be Vietnam Pro" pitchFamily="34" charset="-122"/>
                 <a:cs typeface="Be Vietnam Pro" pitchFamily="34" charset="-120"/>
               </a:rPr>
-              <a:t> làm</a:t>
-            </a:r>
-            <a:r>
-              <a:rPr lang="en-US" sz="2700" dirty="0" spc="-2" kern="0">
-                <a:solidFill>
-                  <a:srgbClr val="C4C8D6"/>
-                </a:solidFill>
-                <a:latin typeface="Be Vietnam Pro" pitchFamily="34" charset="0"/>
-                <a:ea typeface="Be Vietnam Pro" pitchFamily="34" charset="-122"/>
-                <a:cs typeface="Be Vietnam Pro" pitchFamily="34" charset="-120"/>
-              </a:rPr>
-              <a:t> hợp</a:t>
-            </a:r>
-            <a:r>
-              <a:rPr lang="en-US" sz="2700" dirty="0" spc="7" kern="0">
-                <a:solidFill>
-                  <a:srgbClr val="C4C8D6"/>
-                </a:solidFill>
-                <a:latin typeface="Be Vietnam Pro" pitchFamily="34" charset="0"/>
-                <a:ea typeface="Be Vietnam Pro" pitchFamily="34" charset="-122"/>
-                <a:cs typeface="Be Vietnam Pro" pitchFamily="34" charset="-120"/>
-              </a:rPr>
-              <a:t> đồng.</a:t>
+              <a:t> riêng.</a:t>
             </a:r>
             <a:endParaRPr lang="en-US" sz="2700" dirty="0"/>
           </a:p>
@@ -8461,10 +8461,10 @@
                 <a:ea typeface="Be Vietnam Pro" pitchFamily="34" charset="-122"/>
                 <a:cs typeface="Be Vietnam Pro" pitchFamily="34" charset="-120"/>
               </a:rPr>
-              <a:t> DỊCH</a:t>
-            </a:r>
-            <a:r>
-              <a:rPr lang="en-US" sz="1950" b="1" spc="227" kern="0" dirty="0">
+              <a:t> DỊCH VỤ,</a:t>
+            </a:r>
+            <a:r>
+              <a:rPr lang="en-US" sz="1950" b="1" spc="224" kern="0" dirty="0">
                 <a:solidFill>
                   <a:srgbClr val="FF6A4D"/>
                 </a:solidFill>
@@ -8472,7 +8472,7 @@
                 <a:ea typeface="Be Vietnam Pro" pitchFamily="34" charset="-122"/>
                 <a:cs typeface="Be Vietnam Pro" pitchFamily="34" charset="-120"/>
               </a:rPr>
-              <a:t> VỤ</a:t>
+              <a:t> NẾU CÓ</a:t>
             </a:r>
             <a:endParaRPr lang="en-US" sz="1950" dirty="0"/>
           </a:p>
@@ -8503,7 +8503,7 @@
               <a:buNone/>
             </a:pPr>
             <a:r>
-              <a:rPr lang="en-US" sz="2550" dirty="0" spc="-2" kern="0">
+              <a:rPr lang="en-US" sz="2550" dirty="0" spc="1" kern="0">
                 <a:solidFill>
                   <a:srgbClr val="E4E1D8"/>
                 </a:solidFill>
@@ -8511,10 +8511,10 @@
                 <a:ea typeface="Be Vietnam Pro" pitchFamily="34" charset="-122"/>
                 <a:cs typeface="Be Vietnam Pro" pitchFamily="34" charset="-120"/>
               </a:rPr>
-              <a:t>Hai</a:t>
-            </a:r>
-            <a:r>
-              <a:rPr lang="en-US" sz="2550" dirty="0" spc="-3" kern="0">
+              <a:t>Công</a:t>
+            </a:r>
+            <a:r>
+              <a:rPr lang="en-US" sz="2550" dirty="0" spc="-5" kern="0">
                 <a:solidFill>
                   <a:srgbClr val="E4E1D8"/>
                 </a:solidFill>
@@ -8522,10 +8522,10 @@
                 <a:ea typeface="Be Vietnam Pro" pitchFamily="34" charset="-122"/>
                 <a:cs typeface="Be Vietnam Pro" pitchFamily="34" charset="-120"/>
               </a:rPr>
-              <a:t> bên</a:t>
-            </a:r>
-            <a:r>
-              <a:rPr lang="en-US" sz="2550" dirty="0" spc="9" kern="0">
+              <a:t> bố</a:t>
+            </a:r>
+            <a:r>
+              <a:rPr lang="en-US" sz="2550" dirty="0" spc="7" kern="0">
                 <a:solidFill>
                   <a:srgbClr val="E4E1D8"/>
                 </a:solidFill>
@@ -8533,10 +8533,10 @@
                 <a:ea typeface="Be Vietnam Pro" pitchFamily="34" charset="-122"/>
                 <a:cs typeface="Be Vietnam Pro" pitchFamily="34" charset="-120"/>
               </a:rPr>
-              <a:t> đọc</a:t>
-            </a:r>
-            <a:r>
-              <a:rPr lang="en-US" sz="2550" dirty="0" spc="1" kern="0">
+              <a:t> riêng,</a:t>
+            </a:r>
+            <a:r>
+              <a:rPr lang="en-US" sz="2550" dirty="0" spc="0" kern="0">
                 <a:solidFill>
                   <a:srgbClr val="E4E1D8"/>
                 </a:solidFill>
@@ -8544,10 +8544,10 @@
                 <a:ea typeface="Be Vietnam Pro" pitchFamily="34" charset="-122"/>
                 <a:cs typeface="Be Vietnam Pro" pitchFamily="34" charset="-120"/>
               </a:rPr>
-              <a:t> chung</a:t>
-            </a:r>
-            <a:r>
-              <a:rPr lang="en-US" sz="2550" dirty="0" spc="-5" kern="0">
+              <a:t> không</a:t>
+            </a:r>
+            <a:r>
+              <a:rPr lang="en-US" sz="2550" dirty="0" spc="40" kern="0">
                 <a:solidFill>
                   <a:srgbClr val="E4E1D8"/>
                 </a:solidFill>
@@ -8555,10 +8555,10 @@
                 <a:ea typeface="Be Vietnam Pro" pitchFamily="34" charset="-122"/>
                 <a:cs typeface="Be Vietnam Pro" pitchFamily="34" charset="-120"/>
               </a:rPr>
-              <a:t> một</a:t>
-            </a:r>
-            <a:r>
-              <a:rPr lang="en-US" sz="2550" dirty="0" spc="0" kern="0">
+              <a:t> gửi</a:t>
+            </a:r>
+            <a:r>
+              <a:rPr lang="en-US" sz="2550" dirty="0" spc="-27" kern="0">
                 <a:solidFill>
                   <a:srgbClr val="E4E1D8"/>
                 </a:solidFill>
@@ -8566,10 +8566,10 @@
                 <a:ea typeface="Be Vietnam Pro" pitchFamily="34" charset="-122"/>
                 <a:cs typeface="Be Vietnam Pro" pitchFamily="34" charset="-120"/>
               </a:rPr>
-              <a:t> hợp</a:t>
-            </a:r>
-            <a:r>
-              <a:rPr lang="en-US" sz="2550" dirty="0" spc="10" kern="0">
+              <a:t> kèm</a:t>
+            </a:r>
+            <a:r>
+              <a:rPr lang="en-US" sz="2550" dirty="0" spc="-20" kern="0">
                 <a:solidFill>
                   <a:srgbClr val="E4E1D8"/>
                 </a:solidFill>
@@ -8577,7 +8577,18 @@
                 <a:ea typeface="Be Vietnam Pro" pitchFamily="34" charset="-122"/>
                 <a:cs typeface="Be Vietnam Pro" pitchFamily="34" charset="-120"/>
               </a:rPr>
-              <a:t> đồng</a:t>
+              <a:t> yêu</a:t>
+            </a:r>
+            <a:r>
+              <a:rPr lang="en-US" sz="2550" dirty="0" spc="2" kern="0">
+                <a:solidFill>
+                  <a:srgbClr val="E4E1D8"/>
+                </a:solidFill>
+                <a:latin typeface="Be Vietnam Pro" pitchFamily="34" charset="0"/>
+                <a:ea typeface="Be Vietnam Pro" pitchFamily="34" charset="-122"/>
+                <a:cs typeface="Be Vietnam Pro" pitchFamily="34" charset="-120"/>
+              </a:rPr>
+              <a:t> cầu</a:t>
             </a:r>
             <a:endParaRPr lang="en-US" sz="2550" dirty="0"/>
           </a:p>

</xml_diff>